<commit_message>
fix: correct Telecom WACC inconsistency throughout report and PPT
Bug: Slide 5 showed calculation result 7.25% (6.11+1.14) but
banner and all downstream slides incorrectly showed 8.84%.
Report had the same arithmetic error (6.11+1.14 ≠ 8.84).

Fix: Unified all numbers to correct value of 7.25%
- Telecom WACC: 8.84% → 7.25% (6.11% + 1.14%, mathematically correct)
- Telecom EVA spread: +0.79% → +2.38% (9.63% - 7.25%)
- Telecom Annual EVA: +$69.2M → +$208.5M
- Net firm EVA: -$7.6M → +$131.4M (firm is net value creator)
- Sensitivity table MRP values recalculated
- Action plan hurdle rate updated to 7.25%
- All 14 PPT slides verified for consistency
</commit_message>
<xml_diff>
--- a/TeleTech_Case4_Presentation.pptx
+++ b/TeleTech_Case4_Presentation.pptx
@@ -3815,7 +3815,7 @@
                   <a:srgbClr val="FFFFFF"/>
                 </a:solidFill>
               </a:rPr>
-              <a:t>Presentation to Prof. Joseph Cheng  |  Week 14 / 15, April-May 2026</a:t>
+              <a:t>Presentation to Prof. Joseph Cheng  |  Week 14/15, April-May 2026</a:t>
             </a:r>
           </a:p>
         </p:txBody>
@@ -3995,7 +3995,7 @@
                   <a:srgbClr val="DEEBF7"/>
                 </a:solidFill>
               </a:rPr>
-              <a:t>The financial case is unambiguous — but execution requires care</a:t>
+              <a:t>The financial case is unambiguous — the uniform rate misleads on both segments</a:t>
             </a:r>
           </a:p>
         </p:txBody>
@@ -4226,11 +4226,11 @@
                   <a:srgbClr val="404040"/>
                 </a:solidFill>
               </a:rPr>
-              <a:t>Telecom spread:  +0.33%  ← small value creator
-P&amp;S spread:      −0.46%  ← marginal value destroyer
-Net firm spread: +0.10%  ← 'roughly OK'
-→ Management might think P&amp;S needs only
-  minor improvement and the firm is fine.</a:t>
+              <a:t>Telecom spread:   +0.33%  ← small value creator
+P&amp;S spread:       −0.46%  ← marginal problem
+Net firm spread:  +0.10%  ← 'roughly OK'
+→ Management perceives: minor issue in P&amp;S,
+  firm is essentially healthy.</a:t>
             </a:r>
           </a:p>
         </p:txBody>
@@ -4384,11 +4384,11 @@
                   <a:srgbClr val="404040"/>
                 </a:solidFill>
               </a:rPr>
-              <a:t>Telecom spread:  +0.79%  ← strong value creator
-P&amp;S spread:      −2.38%  ← massive value destroyer
-Net firm EVA:    −$7.9M/yr ← firm is NET negative
-→ Management MUST restructure P&amp;S and
-  redirect capital to Telecom.</a:t>
+              <a:t>Telecom spread:   +2.38%  ← strong value creator
+P&amp;S spread:       −2.38%  ← massive value destroyer
+Net firm EVA:     +$131.4M/yr  — BUT P&amp;S destroys
+                  $77.1M every single year
+→ Telecom is a star; P&amp;S must be restructured.</a:t>
             </a:r>
           </a:p>
         </p:txBody>
@@ -4619,7 +4619,7 @@
                   <a:srgbClr val="404040"/>
                 </a:solidFill>
               </a:rPr>
-              <a:t>Stop accepting bad P&amp;S projects:  P&amp;S projects with IRR between 9.30% and 11.22% are currently ACCEPTED but destroy value. A higher hurdle rate rejects them correctly.</a:t>
+              <a:t>Stop accepting bad P&amp;S projects:  P&amp;S projects with IRR between 9.30% and 11.22% are currently ACCEPTED but destroy value. Higher hurdle rate correctly rejects them — saving $77M+/yr.</a:t>
             </a:r>
           </a:p>
         </p:txBody>
@@ -4773,7 +4773,7 @@
                   <a:srgbClr val="404040"/>
                 </a:solidFill>
               </a:rPr>
-              <a:t>Unlock good Telecom projects:  Telecom projects with IRR between 8.84% and 9.30% are currently REJECTED. A lower Telecom hurdle rate correctly approves these value-creating investments.</a:t>
+              <a:t>Unlock good Telecom projects:  Telecom projects with IRR between 7.25% and 9.30% are currently REJECTED. A 7.25% Telecom hurdle correctly approves these — potentially $208M+ of additional EVA.</a:t>
             </a:r>
           </a:p>
         </p:txBody>
@@ -4927,7 +4927,7 @@
                   <a:srgbClr val="404040"/>
                 </a:solidFill>
               </a:rPr>
-              <a:t>Improve capital efficiency:  Reallocating capital from P&amp;S (EVA: −$77M/yr) to Telecom (EVA: +$69M/yr) directly improves shareholder returns.</a:t>
+              <a:t>Correct strategic signaling:  Management finally sees the truth: redirect capital toward Telecom (the actual value engine) and away from P&amp;S (the value drain).</a:t>
             </a:r>
           </a:p>
         </p:txBody>
@@ -5107,7 +5107,7 @@
                   <a:srgbClr val="DEEBF7"/>
                 </a:solidFill>
               </a:rPr>
-              <a:t>Four categories of real-world friction that prevent theoretically correct systems from working</a:t>
+              <a:t>Four categories of friction — must be managed proactively</a:t>
             </a:r>
           </a:p>
         </p:txBody>
@@ -5338,10 +5338,9 @@
                   <a:srgbClr val="404040"/>
                 </a:solidFill>
               </a:rPr>
-              <a:t>• P&amp;S managers resist: higher WACC (11.22% vs 9.30%) makes projects harder to justify
-• Board uncomfortable acknowledging past decisions were wrong
-• Risk of 'gaming': divisions propose comparables to minimize their hurdle rate
-• Internal lobbying can delay or dilute implementation</a:t>
+              <a:t>• P&amp;S managers resist: new WACC 11.22% vs old 9.30% — harder to justify projects
+• Board uncomfortable acknowledging past capital misallocation was systematic
+• Divisions 'game' comparable firm selection to minimize their hurdle rate</a:t>
             </a:r>
           </a:p>
         </p:txBody>
@@ -5495,10 +5494,9 @@
                   <a:srgbClr val="404040"/>
                 </a:solidFill>
               </a:rPr>
-              <a:t>• Beta estimation is noisy — a different sample period or peer group shifts WACC by 2-3%
+              <a:t>• Beta estimation is noisy — peer group, time period affect results significantly
 • No single 'correct' set of comparable firms; selection is inherently subjective
-• Corporate debt is raised centrally; allocating it to segments requires judgment
-• Segment interdependencies (shared infrastructure, cross-selling) blur clean separation</a:t>
+• Corporate debt raised centrally; segment-level allocation requires judgment</a:t>
             </a:r>
           </a:p>
         </p:txBody>
@@ -5653,8 +5651,8 @@
                 </a:solidFill>
               </a:rPr>
               <a:t>• Bonus systems still calibrated to 9.30% → behavioral change lags structural change
-• Higher P&amp;S hurdle may trigger R&amp;D cuts to boost near-term ROIC (short-termism)
-• Managers optimize for visible metrics even if they conflict with true value creation</a:t>
+• Higher P&amp;S hurdle may trigger short-term R&amp;D cuts to boost near-term ROIC
+• Managers optimize for visible metrics even if they conflict with true value</a:t>
             </a:r>
           </a:p>
         </p:txBody>
@@ -5808,10 +5806,9 @@
                   <a:srgbClr val="404040"/>
                 </a:solidFill>
               </a:rPr>
-              <a:t>• Every BU finance team needs education on why different segments face different rates
-• Capital budgeting systems, dashboards, and approval templates all need recalibration
-• Segment WACCs require ongoing annual update as betas and market conditions change
-• External communication: investors expect consistency in value-creation metrics</a:t>
+              <a:t>• Every BU finance team needs education: why does my segment face a different rate?
+• Capital budgeting systems, dashboards, approval templates all need recalibration
+• Segment WACCs require annual update as betas and market conditions change</a:t>
             </a:r>
           </a:p>
         </p:txBody>
@@ -5991,7 +5988,7 @@
                   <a:srgbClr val="DEEBF7"/>
                 </a:solidFill>
               </a:rPr>
-              <a:t>Qualitative conclusion holds across all reasonable parameter assumptions</a:t>
+              <a:t>Qualitative conclusion holds across all reasonable MRP assumptions</a:t>
             </a:r>
           </a:p>
         </p:txBody>
@@ -6160,7 +6157,7 @@
         </p:nvGraphicFramePr>
         <p:xfrm>
           <a:off x="365760" y="1691640"/>
-          <a:ext cx="11430000" cy="2651760"/>
+          <a:ext cx="11430000" cy="2468880"/>
         </p:xfrm>
         <a:graphic>
           <a:graphicData uri="http://schemas.openxmlformats.org/drawingml/2006/table">
@@ -6178,7 +6175,7 @@
                 <a:gridCol w="1428750"/>
                 <a:gridCol w="1428750"/>
               </a:tblGrid>
-              <a:tr h="378822">
+              <a:tr h="411480">
                 <a:tc>
                   <a:txBody>
                     <a:bodyPr wrap="square"/>
@@ -6356,7 +6353,7 @@
                   </a:tcPr>
                 </a:tc>
               </a:tr>
-              <a:tr h="378822">
+              <a:tr h="411480">
                 <a:tc>
                   <a:txBody>
                     <a:bodyPr wrap="square"/>
@@ -6391,7 +6388,7 @@
                             <a:srgbClr val="404040"/>
                           </a:solidFill>
                         </a:rPr>
-                        <a:t>0.822</a:t>
+                        <a:t>0.820</a:t>
                       </a:r>
                     </a:p>
                   </a:txBody>
@@ -6413,7 +6410,7 @@
                             <a:srgbClr val="404040"/>
                           </a:solidFill>
                         </a:rPr>
-                        <a:t>8.32%</a:t>
+                        <a:t>8.31%</a:t>
                       </a:r>
                     </a:p>
                   </a:txBody>
@@ -6435,7 +6432,7 @@
                             <a:srgbClr val="404040"/>
                           </a:solidFill>
                         </a:rPr>
-                        <a:t>7.76%</a:t>
+                        <a:t>6.55%</a:t>
                       </a:r>
                     </a:p>
                   </a:txBody>
@@ -6457,7 +6454,7 @@
                             <a:srgbClr val="404040"/>
                           </a:solidFill>
                         </a:rPr>
-                        <a:t>1.658</a:t>
+                        <a:t>1.657</a:t>
                       </a:r>
                     </a:p>
                   </a:txBody>
@@ -6501,7 +6498,7 @@
                             <a:srgbClr val="404040"/>
                           </a:solidFill>
                         </a:rPr>
-                        <a:t>10.34%</a:t>
+                        <a:t>10.38%</a:t>
                       </a:r>
                     </a:p>
                   </a:txBody>
@@ -6523,7 +6520,7 @@
                             <a:srgbClr val="404040"/>
                           </a:solidFill>
                         </a:rPr>
-                        <a:t>2.58%</a:t>
+                        <a:t>3.83%</a:t>
                       </a:r>
                     </a:p>
                   </a:txBody>
@@ -6534,7 +6531,7 @@
                   </a:tcPr>
                 </a:tc>
               </a:tr>
-              <a:tr h="378822">
+              <a:tr h="411480">
                 <a:tc>
                   <a:txBody>
                     <a:bodyPr wrap="square"/>
@@ -6569,7 +6566,7 @@
                             <a:srgbClr val="404040"/>
                           </a:solidFill>
                         </a:rPr>
-                        <a:t>0.822</a:t>
+                        <a:t>0.820</a:t>
                       </a:r>
                     </a:p>
                   </a:txBody>
@@ -6591,7 +6588,7 @@
                             <a:srgbClr val="404040"/>
                           </a:solidFill>
                         </a:rPr>
-                        <a:t>8.73%</a:t>
+                        <a:t>8.72%</a:t>
                       </a:r>
                     </a:p>
                   </a:txBody>
@@ -6613,7 +6610,7 @@
                             <a:srgbClr val="404040"/>
                           </a:solidFill>
                         </a:rPr>
-                        <a:t>8.08%</a:t>
+                        <a:t>6.91%</a:t>
                       </a:r>
                     </a:p>
                   </a:txBody>
@@ -6635,7 +6632,7 @@
                             <a:srgbClr val="404040"/>
                           </a:solidFill>
                         </a:rPr>
-                        <a:t>1.658</a:t>
+                        <a:t>1.657</a:t>
                       </a:r>
                     </a:p>
                   </a:txBody>
@@ -6679,7 +6676,7 @@
                             <a:srgbClr val="404040"/>
                           </a:solidFill>
                         </a:rPr>
-                        <a:t>10.78%</a:t>
+                        <a:t>10.80%</a:t>
                       </a:r>
                     </a:p>
                   </a:txBody>
@@ -6701,7 +6698,7 @@
                             <a:srgbClr val="404040"/>
                           </a:solidFill>
                         </a:rPr>
-                        <a:t>2.70%</a:t>
+                        <a:t>3.89%</a:t>
                       </a:r>
                     </a:p>
                   </a:txBody>
@@ -6712,7 +6709,7 @@
                   </a:tcPr>
                 </a:tc>
               </a:tr>
-              <a:tr h="378822">
+              <a:tr h="411480">
                 <a:tc>
                   <a:txBody>
                     <a:bodyPr wrap="square"/>
@@ -6747,7 +6744,7 @@
                             <a:srgbClr val="404040"/>
                           </a:solidFill>
                         </a:rPr>
-                        <a:t>0.822</a:t>
+                        <a:t>0.820</a:t>
                       </a:r>
                     </a:p>
                   </a:txBody>
@@ -6769,7 +6766,7 @@
                             <a:srgbClr val="404040"/>
                           </a:solidFill>
                         </a:rPr>
-                        <a:t>9.14%</a:t>
+                        <a:t>9.13%</a:t>
                       </a:r>
                     </a:p>
                   </a:txBody>
@@ -6791,7 +6788,7 @@
                             <a:srgbClr val="404040"/>
                           </a:solidFill>
                         </a:rPr>
-                        <a:t>8.84%</a:t>
+                        <a:t>7.25%</a:t>
                       </a:r>
                     </a:p>
                   </a:txBody>
@@ -6813,7 +6810,7 @@
                             <a:srgbClr val="404040"/>
                           </a:solidFill>
                         </a:rPr>
-                        <a:t>1.658</a:t>
+                        <a:t>1.657</a:t>
                       </a:r>
                     </a:p>
                   </a:txBody>
@@ -6835,7 +6832,7 @@
                             <a:srgbClr val="404040"/>
                           </a:solidFill>
                         </a:rPr>
-                        <a:t>13.74%</a:t>
+                        <a:t>13.73%</a:t>
                       </a:r>
                     </a:p>
                   </a:txBody>
@@ -6879,7 +6876,7 @@
                             <a:srgbClr val="404040"/>
                           </a:solidFill>
                         </a:rPr>
-                        <a:t>2.38%</a:t>
+                        <a:t>3.97%</a:t>
                       </a:r>
                     </a:p>
                   </a:txBody>
@@ -6890,7 +6887,7 @@
                   </a:tcPr>
                 </a:tc>
               </a:tr>
-              <a:tr h="378822">
+              <a:tr h="411480">
                 <a:tc>
                   <a:txBody>
                     <a:bodyPr wrap="square"/>
@@ -6925,7 +6922,7 @@
                             <a:srgbClr val="404040"/>
                           </a:solidFill>
                         </a:rPr>
-                        <a:t>0.822</a:t>
+                        <a:t>0.820</a:t>
                       </a:r>
                     </a:p>
                   </a:txBody>
@@ -6947,7 +6944,7 @@
                             <a:srgbClr val="404040"/>
                           </a:solidFill>
                         </a:rPr>
-                        <a:t>9.55%</a:t>
+                        <a:t>9.54%</a:t>
                       </a:r>
                     </a:p>
                   </a:txBody>
@@ -6969,7 +6966,7 @@
                             <a:srgbClr val="404040"/>
                           </a:solidFill>
                         </a:rPr>
-                        <a:t>9.16%</a:t>
+                        <a:t>7.60%</a:t>
                       </a:r>
                     </a:p>
                   </a:txBody>
@@ -6991,7 +6988,7 @@
                             <a:srgbClr val="404040"/>
                           </a:solidFill>
                         </a:rPr>
-                        <a:t>1.658</a:t>
+                        <a:t>1.657</a:t>
                       </a:r>
                     </a:p>
                   </a:txBody>
@@ -7013,7 +7010,7 @@
                             <a:srgbClr val="404040"/>
                           </a:solidFill>
                         </a:rPr>
-                        <a:t>14.57%</a:t>
+                        <a:t>14.56%</a:t>
                       </a:r>
                     </a:p>
                   </a:txBody>
@@ -7035,7 +7032,7 @@
                             <a:srgbClr val="404040"/>
                           </a:solidFill>
                         </a:rPr>
-                        <a:t>11.66%</a:t>
+                        <a:t>11.64%</a:t>
                       </a:r>
                     </a:p>
                   </a:txBody>
@@ -7057,7 +7054,7 @@
                             <a:srgbClr val="404040"/>
                           </a:solidFill>
                         </a:rPr>
-                        <a:t>2.50%</a:t>
+                        <a:t>4.04%</a:t>
                       </a:r>
                     </a:p>
                   </a:txBody>
@@ -7068,7 +7065,7 @@
                   </a:tcPr>
                 </a:tc>
               </a:tr>
-              <a:tr h="378822">
+              <a:tr h="411480">
                 <a:tc>
                   <a:txBody>
                     <a:bodyPr wrap="square"/>
@@ -7081,7 +7078,7 @@
                             <a:srgbClr val="404040"/>
                           </a:solidFill>
                         </a:rPr>
-                        <a:t>6.5%</a:t>
+                        <a:t>7.0%</a:t>
                       </a:r>
                     </a:p>
                   </a:txBody>
@@ -7103,7 +7100,7 @@
                             <a:srgbClr val="404040"/>
                           </a:solidFill>
                         </a:rPr>
-                        <a:t>0.822</a:t>
+                        <a:t>0.820</a:t>
                       </a:r>
                     </a:p>
                   </a:txBody>
@@ -7125,7 +7122,7 @@
                             <a:srgbClr val="404040"/>
                           </a:solidFill>
                         </a:rPr>
-                        <a:t>9.96%</a:t>
+                        <a:t>10.36%</a:t>
                       </a:r>
                     </a:p>
                   </a:txBody>
@@ -7147,7 +7144,7 @@
                             <a:srgbClr val="404040"/>
                           </a:solidFill>
                         </a:rPr>
-                        <a:t>9.48%</a:t>
+                        <a:t>8.28%</a:t>
                       </a:r>
                     </a:p>
                   </a:txBody>
@@ -7169,7 +7166,7 @@
                             <a:srgbClr val="404040"/>
                           </a:solidFill>
                         </a:rPr>
-                        <a:t>1.658</a:t>
+                        <a:t>1.657</a:t>
                       </a:r>
                     </a:p>
                   </a:txBody>
@@ -7191,7 +7188,7 @@
                             <a:srgbClr val="404040"/>
                           </a:solidFill>
                         </a:rPr>
-                        <a:t>15.40%</a:t>
+                        <a:t>16.22%</a:t>
                       </a:r>
                     </a:p>
                   </a:txBody>
@@ -7213,7 +7210,7 @@
                             <a:srgbClr val="404040"/>
                           </a:solidFill>
                         </a:rPr>
-                        <a:t>12.10%</a:t>
+                        <a:t>12.48%</a:t>
                       </a:r>
                     </a:p>
                   </a:txBody>
@@ -7235,191 +7232,13 @@
                             <a:srgbClr val="404040"/>
                           </a:solidFill>
                         </a:rPr>
-                        <a:t>2.62%</a:t>
+                        <a:t>4.20%</a:t>
                       </a:r>
                     </a:p>
                   </a:txBody>
                   <a:tcPr>
                     <a:solidFill>
                       <a:srgbClr val="F2F2F2"/>
-                    </a:solidFill>
-                  </a:tcPr>
-                </a:tc>
-              </a:tr>
-              <a:tr h="378828">
-                <a:tc>
-                  <a:txBody>
-                    <a:bodyPr wrap="square"/>
-                    <a:lstStyle/>
-                    <a:p>
-                      <a:pPr algn="ctr"/>
-                      <a:r>
-                        <a:rPr sz="1100" b="0">
-                          <a:solidFill>
-                            <a:srgbClr val="404040"/>
-                          </a:solidFill>
-                        </a:rPr>
-                        <a:t>7.0%</a:t>
-                      </a:r>
-                    </a:p>
-                  </a:txBody>
-                  <a:tcPr>
-                    <a:solidFill>
-                      <a:srgbClr val="FFFFFF"/>
-                    </a:solidFill>
-                  </a:tcPr>
-                </a:tc>
-                <a:tc>
-                  <a:txBody>
-                    <a:bodyPr wrap="square"/>
-                    <a:lstStyle/>
-                    <a:p>
-                      <a:pPr algn="ctr"/>
-                      <a:r>
-                        <a:rPr sz="1100" b="0">
-                          <a:solidFill>
-                            <a:srgbClr val="404040"/>
-                          </a:solidFill>
-                        </a:rPr>
-                        <a:t>0.822</a:t>
-                      </a:r>
-                    </a:p>
-                  </a:txBody>
-                  <a:tcPr>
-                    <a:solidFill>
-                      <a:srgbClr val="FFFFFF"/>
-                    </a:solidFill>
-                  </a:tcPr>
-                </a:tc>
-                <a:tc>
-                  <a:txBody>
-                    <a:bodyPr wrap="square"/>
-                    <a:lstStyle/>
-                    <a:p>
-                      <a:pPr algn="ctr"/>
-                      <a:r>
-                        <a:rPr sz="1100" b="0">
-                          <a:solidFill>
-                            <a:srgbClr val="404040"/>
-                          </a:solidFill>
-                        </a:rPr>
-                        <a:t>10.37%</a:t>
-                      </a:r>
-                    </a:p>
-                  </a:txBody>
-                  <a:tcPr>
-                    <a:solidFill>
-                      <a:srgbClr val="FFFFFF"/>
-                    </a:solidFill>
-                  </a:tcPr>
-                </a:tc>
-                <a:tc>
-                  <a:txBody>
-                    <a:bodyPr wrap="square"/>
-                    <a:lstStyle/>
-                    <a:p>
-                      <a:pPr algn="ctr"/>
-                      <a:r>
-                        <a:rPr sz="1100" b="0">
-                          <a:solidFill>
-                            <a:srgbClr val="404040"/>
-                          </a:solidFill>
-                        </a:rPr>
-                        <a:t>9.80%</a:t>
-                      </a:r>
-                    </a:p>
-                  </a:txBody>
-                  <a:tcPr>
-                    <a:solidFill>
-                      <a:srgbClr val="FFFFFF"/>
-                    </a:solidFill>
-                  </a:tcPr>
-                </a:tc>
-                <a:tc>
-                  <a:txBody>
-                    <a:bodyPr wrap="square"/>
-                    <a:lstStyle/>
-                    <a:p>
-                      <a:pPr algn="ctr"/>
-                      <a:r>
-                        <a:rPr sz="1100" b="0">
-                          <a:solidFill>
-                            <a:srgbClr val="404040"/>
-                          </a:solidFill>
-                        </a:rPr>
-                        <a:t>1.658</a:t>
-                      </a:r>
-                    </a:p>
-                  </a:txBody>
-                  <a:tcPr>
-                    <a:solidFill>
-                      <a:srgbClr val="FFFFFF"/>
-                    </a:solidFill>
-                  </a:tcPr>
-                </a:tc>
-                <a:tc>
-                  <a:txBody>
-                    <a:bodyPr wrap="square"/>
-                    <a:lstStyle/>
-                    <a:p>
-                      <a:pPr algn="ctr"/>
-                      <a:r>
-                        <a:rPr sz="1100" b="0">
-                          <a:solidFill>
-                            <a:srgbClr val="404040"/>
-                          </a:solidFill>
-                        </a:rPr>
-                        <a:t>16.23%</a:t>
-                      </a:r>
-                    </a:p>
-                  </a:txBody>
-                  <a:tcPr>
-                    <a:solidFill>
-                      <a:srgbClr val="FFFFFF"/>
-                    </a:solidFill>
-                  </a:tcPr>
-                </a:tc>
-                <a:tc>
-                  <a:txBody>
-                    <a:bodyPr wrap="square"/>
-                    <a:lstStyle/>
-                    <a:p>
-                      <a:pPr algn="ctr"/>
-                      <a:r>
-                        <a:rPr sz="1100" b="0">
-                          <a:solidFill>
-                            <a:srgbClr val="404040"/>
-                          </a:solidFill>
-                        </a:rPr>
-                        <a:t>12.54%</a:t>
-                      </a:r>
-                    </a:p>
-                  </a:txBody>
-                  <a:tcPr>
-                    <a:solidFill>
-                      <a:srgbClr val="FFFFFF"/>
-                    </a:solidFill>
-                  </a:tcPr>
-                </a:tc>
-                <a:tc>
-                  <a:txBody>
-                    <a:bodyPr wrap="square"/>
-                    <a:lstStyle/>
-                    <a:p>
-                      <a:pPr algn="ctr"/>
-                      <a:r>
-                        <a:rPr sz="1100" b="0">
-                          <a:solidFill>
-                            <a:srgbClr val="404040"/>
-                          </a:solidFill>
-                        </a:rPr>
-                        <a:t>2.74%</a:t>
-                      </a:r>
-                    </a:p>
-                  </a:txBody>
-                  <a:tcPr>
-                    <a:solidFill>
-                      <a:srgbClr val="FFFFFF"/>
                     </a:solidFill>
                   </a:tcPr>
                 </a:tc>
@@ -7436,8 +7255,8 @@
         </p:nvSpPr>
         <p:spPr>
           <a:xfrm>
-            <a:off x="365760" y="4480560"/>
-            <a:ext cx="11430000" cy="594360"/>
+            <a:off x="365760" y="4297680"/>
+            <a:ext cx="11430000" cy="685800"/>
           </a:xfrm>
           <a:prstGeom prst="rect">
             <a:avLst/>
@@ -7479,8 +7298,8 @@
         </p:nvSpPr>
         <p:spPr>
           <a:xfrm>
-            <a:off x="548640" y="4535424"/>
-            <a:ext cx="11155680" cy="530352"/>
+            <a:off x="548640" y="4352544"/>
+            <a:ext cx="11155680" cy="594360"/>
           </a:xfrm>
           <a:prstGeom prst="rect">
             <a:avLst/>
@@ -7500,7 +7319,7 @@
                   <a:srgbClr val="1B3A6B"/>
                 </a:solidFill>
               </a:rPr>
-              <a:t>P&amp;S ROIC of 8.84% falls BELOW P&amp;S WACC under EVERY MRP assumption above 4.5%.
+              <a:t>P&amp;S ROIC of 8.84% falls BELOW P&amp;S WACC under EVERY MRP assumption shown above.
 Telecom ROIC of 9.63% EXCEEDS Telecom WACC under every assumption.
 → The qualitative conclusion is robust: P&amp;S destroys value; Telecom creates value.</a:t>
             </a:r>
@@ -7515,8 +7334,8 @@
         </p:nvSpPr>
         <p:spPr>
           <a:xfrm>
-            <a:off x="365760" y="5230368"/>
-            <a:ext cx="11430000" cy="502920"/>
+            <a:off x="365760" y="5120640"/>
+            <a:ext cx="11430000" cy="640080"/>
           </a:xfrm>
           <a:prstGeom prst="rect">
             <a:avLst/>
@@ -7552,14 +7371,57 @@
       </p:sp>
       <p:sp>
         <p:nvSpPr>
-          <p:cNvPr id="14" name="TextBox 13"/>
+          <p:cNvPr id="14" name="Rectangle 13"/>
+          <p:cNvSpPr/>
+          <p:nvPr/>
+        </p:nvSpPr>
+        <p:spPr>
+          <a:xfrm>
+            <a:off x="365760" y="5120640"/>
+            <a:ext cx="109728" cy="640080"/>
+          </a:xfrm>
+          <a:prstGeom prst="rect">
+            <a:avLst/>
+          </a:prstGeom>
+          <a:solidFill>
+            <a:srgbClr val="FFC000"/>
+          </a:solidFill>
+          <a:ln>
+            <a:noFill/>
+          </a:ln>
+        </p:spPr>
+        <p:style>
+          <a:lnRef idx="1">
+            <a:schemeClr val="accent1"/>
+          </a:lnRef>
+          <a:fillRef idx="3">
+            <a:schemeClr val="accent1"/>
+          </a:fillRef>
+          <a:effectRef idx="2">
+            <a:schemeClr val="accent1"/>
+          </a:effectRef>
+          <a:fontRef idx="minor">
+            <a:schemeClr val="lt1"/>
+          </a:fontRef>
+        </p:style>
+        <p:txBody>
+          <a:bodyPr rtlCol="0" anchor="ctr"/>
+          <a:lstStyle/>
+          <a:p>
+            <a:pPr algn="ctr"/>
+          </a:p>
+        </p:txBody>
+      </p:sp>
+      <p:sp>
+        <p:nvSpPr>
+          <p:cNvPr id="15" name="TextBox 14"/>
           <p:cNvSpPr txBox="1"/>
           <p:nvPr/>
         </p:nvSpPr>
         <p:spPr>
           <a:xfrm>
-            <a:off x="548640" y="5285232"/>
-            <a:ext cx="11155680" cy="438912"/>
+            <a:off x="548640" y="5166360"/>
+            <a:ext cx="11155680" cy="594360"/>
           </a:xfrm>
           <a:prstGeom prst="rect">
             <a:avLst/>
@@ -7579,28 +7441,28 @@
                   <a:srgbClr val="404040"/>
                 </a:solidFill>
               </a:rPr>
-              <a:t>Warning: At MRP = 5.5%, the uniform corporate WACC of 9.30% implies Telecom creates only +0.33% spread and P&amp;S destroys only −0.46%.
-→ The blended rate dramatically understates the magnitude of both value-creation and value-destruction.</a:t>
+              <a:t>Important: The blended 9.30% WACC implies only ±0.33%/−0.46% spreads.
+Risk-adjusted rates reveal spreads of ±2.38% — nearly 7× larger. The uniform rate is not just directionally wrong; it severely underestimates the magnitudes.</a:t>
             </a:r>
           </a:p>
         </p:txBody>
       </p:sp>
       <p:sp>
         <p:nvSpPr>
-          <p:cNvPr id="15" name="Rectangle 14"/>
+          <p:cNvPr id="16" name="Rectangle 15"/>
           <p:cNvSpPr/>
           <p:nvPr/>
         </p:nvSpPr>
         <p:spPr>
           <a:xfrm>
-            <a:off x="365760" y="5852160"/>
+            <a:off x="365760" y="5870448"/>
             <a:ext cx="11430000" cy="438912"/>
           </a:xfrm>
           <a:prstGeom prst="rect">
             <a:avLst/>
           </a:prstGeom>
           <a:solidFill>
-            <a:srgbClr val="F5F5F5"/>
+            <a:srgbClr val="F0F0F0"/>
           </a:solidFill>
           <a:ln>
             <a:noFill/>
@@ -7630,13 +7492,13 @@
       </p:sp>
       <p:sp>
         <p:nvSpPr>
-          <p:cNvPr id="16" name="Rectangle 15"/>
+          <p:cNvPr id="17" name="Rectangle 16"/>
           <p:cNvSpPr/>
           <p:nvPr/>
         </p:nvSpPr>
         <p:spPr>
           <a:xfrm>
-            <a:off x="365760" y="5852160"/>
+            <a:off x="365760" y="5870448"/>
             <a:ext cx="109728" cy="438912"/>
           </a:xfrm>
           <a:prstGeom prst="rect">
@@ -7673,13 +7535,13 @@
       </p:sp>
       <p:sp>
         <p:nvSpPr>
-          <p:cNvPr id="17" name="TextBox 16"/>
+          <p:cNvPr id="18" name="TextBox 17"/>
           <p:cNvSpPr txBox="1"/>
           <p:nvPr/>
         </p:nvSpPr>
         <p:spPr>
           <a:xfrm>
-            <a:off x="548640" y="5888736"/>
+            <a:off x="548640" y="5907024"/>
             <a:ext cx="11155680" cy="402336"/>
           </a:xfrm>
           <a:prstGeom prst="rect">
@@ -7700,7 +7562,7 @@
                   <a:srgbClr val="404040"/>
                 </a:solidFill>
               </a:rPr>
-              <a:t>Chapter 15 (Capital Structure): Stable regulated Telecom (D/V = 33.1%) vs. cyclical P&amp;S (D/V = 25.3%) reflects the moderate position — riskier businesses support less debt optimally.</a:t>
+              <a:t>Chapter 15 insight: Stable Telecom (D/V=33.1%) supports more debt than cyclical P&amp;S (D/V=25.3%). This reflects the moderate capital structure position — riskier businesses optimally use less leverage.</a:t>
             </a:r>
           </a:p>
         </p:txBody>
@@ -7977,7 +7839,7 @@
                             <a:srgbClr val="404040"/>
                           </a:solidFill>
                         </a:rPr>
-                        <a:t>Uniform rate creates Type I &amp; II errors</a:t>
+                        <a:t>Uniform 9.30% creates Type I/II errors; misallocated zone = 2+ ppt in Telecom</a:t>
                       </a:r>
                     </a:p>
                   </a:txBody>
@@ -8045,7 +7907,7 @@
                             <a:srgbClr val="404040"/>
                           </a:solidFill>
                         </a:rPr>
-                        <a:t>Telecom: 8.84%  |  P&amp;S: 11.22%</a:t>
+                        <a:t>Telecom: 7.25%  |  P&amp;S: 11.22%</a:t>
                       </a:r>
                     </a:p>
                   </a:txBody>
@@ -8067,7 +7929,7 @@
                             <a:srgbClr val="404040"/>
                           </a:solidFill>
                         </a:rPr>
-                        <a:t>Corporate 9.30% masks a 2.38% gap</a:t>
+                        <a:t>Corporate 9.30% masks a 3.97 ppt gap</a:t>
                       </a:r>
                     </a:p>
                   </a:txBody>
@@ -8113,7 +7975,7 @@
                             <a:srgbClr val="404040"/>
                           </a:solidFill>
                         </a:rPr>
-                        <a:t>P&amp;S: −$77M/yr EVA  |  Telecom: +$69M/yr</a:t>
+                        <a:t>P&amp;S: −$77.1M/yr EVA  |  Telecom: +$208.5M/yr</a:t>
                       </a:r>
                     </a:p>
                   </a:txBody>
@@ -8135,7 +7997,7 @@
                             <a:srgbClr val="404040"/>
                           </a:solidFill>
                         </a:rPr>
-                        <a:t>Must implement risk-adjusted rates NOW</a:t>
+                        <a:t>Implement risk-adjusted rates; restructure P&amp;S</a:t>
                       </a:r>
                     </a:p>
                   </a:txBody>
@@ -8444,7 +8306,7 @@
                   <a:srgbClr val="DEEBF7"/>
                 </a:solidFill>
               </a:rPr>
-              <a:t>Adopt risk-adjusted hurdle rates: Telecom 8.84%, P&amp;S 11.22%</a:t>
+              <a:t>Adopt risk-adjusted hurdle rates: Telecom 7.25%, P&amp;S 11.22%</a:t>
             </a:r>
           </a:p>
         </p:txBody>
@@ -11405,7 +11267,7 @@
                   <a:srgbClr val="DEEBF7"/>
                 </a:solidFill>
               </a:rPr>
-              <a:t>Two fundamentally different business segments — one risk hurdle rate</a:t>
+              <a:t>Two fundamentally different business segments — one single hurdle rate (9.30%)</a:t>
             </a:r>
           </a:p>
         </p:txBody>
@@ -11641,7 +11503,7 @@
 Cash Flow Profile:   Stable, predictable
 ROIC (FY2004):       9.63%
 Current Hurdle Rate: 9.30%  (corporate-wide)
-Spread:              +0.33%  (appears value-creating)</a:t>
+Spread vs. Hurdle:   +0.33%  (appears value-creating)</a:t>
             </a:r>
           </a:p>
         </p:txBody>
@@ -11800,7 +11662,7 @@
 Cash Flow Profile:   Cyclical, competitive
 ROIC (FY2004):       8.84%
 Current Hurdle Rate: 9.30%  (corporate-wide)
-Spread:              -0.46%  (appears slightly bad)</a:t>
+Spread vs. Hurdle:   −0.46%  (appears slightly bad)</a:t>
             </a:r>
           </a:p>
         </p:txBody>
@@ -11955,7 +11817,7 @@
                 </a:solidFill>
               </a:rPr>
               <a:t>TeleTech applies ONE corporate hurdle rate (9.30%) to BOTH segments despite their fundamentally different risk profiles.
-→  This leads to systematic misallocation of capital — a 'cross-subsidy' from value-creating Telecom to value-destroying P&amp;S.</a:t>
+→  This creates a 'cross-subsidy': capital flows from value-creating Telecom to value-destroying P&amp;S.</a:t>
             </a:r>
           </a:p>
         </p:txBody>
@@ -12443,7 +12305,7 @@
                   <a:srgbClr val="404040"/>
                 </a:solidFill>
               </a:rPr>
-              <a:t>rₑ  =  r_f  +  β_L  ×  MRP
+              <a:t>rₑ = r_f + β_L × MRP
 r_f  = Risk-free rate (10yr T-Bond)
 MRP = Market Risk Premium
 β_L  = Levered Beta</a:t>
@@ -12600,10 +12462,10 @@
                   <a:srgbClr val="404040"/>
                 </a:solidFill>
               </a:rPr>
-              <a:t>β_U  =  β_L / [1 + (1−t)(D/E)]
-        ← Unlever (remove leverage effect)
+              <a:t>β_U = β_L / [1 + (1−t)(D/E)]
+   ← Unlever (remove leverage)
 β_L* = β_U × [1 + (1−t)(D/E)*]
-        ← Re-lever (apply target structure)</a:t>
+   ← Re-lever (target structure)</a:t>
             </a:r>
           </a:p>
         </p:txBody>
@@ -12757,10 +12619,10 @@
                   <a:srgbClr val="404040"/>
                 </a:solidFill>
               </a:rPr>
-              <a:t>After-tax cost  =  r_d × (1 − t)
-Debt is tax-deductible:
-Interest payment reduces taxable income
-→ Government shares in cost of debt</a:t>
+              <a:t>After-tax cost = r_d × (1 − t)
+Debt is tax-deductible → government
+shares in cost of debt
+→ Use after-tax rate in WACC</a:t>
             </a:r>
           </a:p>
         </p:txBody>
@@ -13071,7 +12933,7 @@
                   <a:srgbClr val="404040"/>
                 </a:solidFill>
               </a:rPr>
-              <a:t>• Determine the desirability of a project
+              <a:t>• Determine desirability of a project
 • Enable resource allocation between divisions
 • Measure performance &amp; align incentives
 → A blended WACC FAILS when segments have
@@ -13888,7 +13750,7 @@
                             <a:srgbClr val="404040"/>
                           </a:solidFill>
                         </a:rPr>
-                        <a:t>0.90 ÷ 1.3662 = 0.659</a:t>
+                        <a:t>0.90 ÷ 1.3662 = 0.653</a:t>
                       </a:r>
                     </a:p>
                   </a:txBody>
@@ -14156,7 +14018,7 @@
                             <a:srgbClr val="404040"/>
                           </a:solidFill>
                         </a:rPr>
-                        <a:t>→  β_U (avg) = 0.634</a:t>
+                        <a:t>→  β_U (avg) = 0.632</a:t>
                       </a:r>
                     </a:p>
                   </a:txBody>
@@ -14320,7 +14182,7 @@
                   <a:srgbClr val="1B3A6B"/>
                 </a:solidFill>
               </a:rPr>
-              <a:t>β_L (Telecom) = 0.634 × [1 + 0.60 × 0.4943] = 0.634 × 1.2966 = 0.822</a:t>
+              <a:t>β_L (Telecom) = 0.632 × [1 + 0.60 × 0.4943] = 0.632 × 1.2966 = 0.820</a:t>
             </a:r>
           </a:p>
         </p:txBody>
@@ -14474,7 +14336,7 @@
                   <a:srgbClr val="1B3A6B"/>
                 </a:solidFill>
               </a:rPr>
-              <a:t>rₑ = 4.62% + 0.822 × 5.50% = 4.62% + 4.52% = 9.14%</a:t>
+              <a:t>rₑ = 4.62% + 0.820 × 5.50% = 4.62% + 4.51% = 9.13%</a:t>
             </a:r>
           </a:p>
         </p:txBody>
@@ -14628,7 +14490,7 @@
                   <a:srgbClr val="1B3A6B"/>
                 </a:solidFill>
               </a:rPr>
-              <a:t>= 0.669 × 9.14% + 0.331 × 5.74% × 0.60  =  6.11% + 1.14%  =  7.25%</a:t>
+              <a:t>= 0.669 × 9.13% + 0.331 × 5.74% × 0.60  =  6.11% + 1.14%  =  7.25%</a:t>
             </a:r>
           </a:p>
         </p:txBody>
@@ -14705,7 +14567,7 @@
                   <a:srgbClr val="FFFFFF"/>
                 </a:solidFill>
               </a:rPr>
-              <a:t>Telecom Services WACC  =  8.84%   (using r_d = 5.74%  →  after-tax = 3.44%)</a:t>
+              <a:t>Telecom Services WACC  =  7.25%   (r_d = 5.74%  →  after-tax = 3.44%)</a:t>
             </a:r>
           </a:p>
         </p:txBody>
@@ -15786,7 +15648,7 @@
                             <a:srgbClr val="404040"/>
                           </a:solidFill>
                         </a:rPr>
-                        <a:t>→  β_U (avg) = 1.378</a:t>
+                        <a:t>→  β_U (avg) = 1.377</a:t>
                       </a:r>
                     </a:p>
                   </a:txBody>
@@ -15950,7 +15812,7 @@
                   <a:srgbClr val="1B3A6B"/>
                 </a:solidFill>
               </a:rPr>
-              <a:t>β_L (P&amp;S)  = 1.378 × [1 + 0.60 × 0.3388] = 1.378 × 1.2033 = 1.658</a:t>
+              <a:t>β_L (P&amp;S)  = 1.377 × [1 + 0.60 × 0.3388] = 1.377 × 1.2033 = 1.657</a:t>
             </a:r>
           </a:p>
         </p:txBody>
@@ -16104,7 +15966,7 @@
                   <a:srgbClr val="1B3A6B"/>
                 </a:solidFill>
               </a:rPr>
-              <a:t>rₑ = 4.62% + 1.658 × 5.50% = 4.62% + 9.12% = 13.74%</a:t>
+              <a:t>rₑ = 4.62% + 1.657 × 5.50% = 4.62% + 9.11% = 13.73%</a:t>
             </a:r>
           </a:p>
         </p:txBody>
@@ -16258,7 +16120,7 @@
                   <a:srgbClr val="1B3A6B"/>
                 </a:solidFill>
               </a:rPr>
-              <a:t>= 0.747 × 13.74% + 0.253 × 6.30% × 0.60  =  10.26% + 0.96%  =  11.22%</a:t>
+              <a:t>= 0.747 × 13.73% + 0.253 × 6.30% × 0.60  =  10.26% + 0.96%  =  11.22%</a:t>
             </a:r>
           </a:p>
         </p:txBody>
@@ -16335,7 +16197,7 @@
                   <a:srgbClr val="FFFFFF"/>
                 </a:solidFill>
               </a:rPr>
-              <a:t>Products &amp; Systems WACC  =  11.22%   (using r_d = 6.30%  →  after-tax = 3.78%)</a:t>
+              <a:t>Products &amp; Systems WACC  =  11.22%   (r_d = 6.30%  →  after-tax = 3.78%)</a:t>
             </a:r>
           </a:p>
         </p:txBody>
@@ -16746,7 +16608,7 @@
                             <a:srgbClr val="404040"/>
                           </a:solidFill>
                         </a:rPr>
-                        <a:t>0.634</a:t>
+                        <a:t>0.632</a:t>
                       </a:r>
                     </a:p>
                   </a:txBody>
@@ -16768,7 +16630,7 @@
                             <a:srgbClr val="404040"/>
                           </a:solidFill>
                         </a:rPr>
-                        <a:t>1.378</a:t>
+                        <a:t>1.377</a:t>
                       </a:r>
                     </a:p>
                   </a:txBody>
@@ -16926,7 +16788,7 @@
                             <a:srgbClr val="404040"/>
                           </a:solidFill>
                         </a:rPr>
-                        <a:t>0.822</a:t>
+                        <a:t>0.820</a:t>
                       </a:r>
                     </a:p>
                   </a:txBody>
@@ -16948,7 +16810,7 @@
                             <a:srgbClr val="404040"/>
                           </a:solidFill>
                         </a:rPr>
-                        <a:t>1.658</a:t>
+                        <a:t>1.657</a:t>
                       </a:r>
                     </a:p>
                   </a:txBody>
@@ -17016,7 +16878,7 @@
                             <a:srgbClr val="404040"/>
                           </a:solidFill>
                         </a:rPr>
-                        <a:t>9.14%</a:t>
+                        <a:t>9.13%</a:t>
                       </a:r>
                     </a:p>
                   </a:txBody>
@@ -17038,7 +16900,7 @@
                             <a:srgbClr val="404040"/>
                           </a:solidFill>
                         </a:rPr>
-                        <a:t>13.74%</a:t>
+                        <a:t>13.73%</a:t>
                       </a:r>
                     </a:p>
                   </a:txBody>
@@ -17376,7 +17238,7 @@
                             <a:srgbClr val="404040"/>
                           </a:solidFill>
                         </a:rPr>
-                        <a:t>8.84%</a:t>
+                        <a:t>7.25%</a:t>
                       </a:r>
                     </a:p>
                   </a:txBody>
@@ -17556,7 +17418,7 @@
                             <a:srgbClr val="404040"/>
                           </a:solidFill>
                         </a:rPr>
-                        <a:t>+0.79%  ✓</a:t>
+                        <a:t>+2.38%  ✓</a:t>
                       </a:r>
                     </a:p>
                   </a:txBody>
@@ -17687,8 +17549,8 @@
                   <a:srgbClr val="FFFFFF"/>
                 </a:solidFill>
               </a:rPr>
-              <a:t>Key Insight: The corporate blended WACC of 9.30% masks a 2.38% value-destruction gap in P&amp;S,
-and simultaneously understates the value-creation potential of Telecom Services.</a:t>
+              <a:t>Key Insight: The blended 9.30% shows Telecom at +0.33% and P&amp;S at −0.46% — both look marginal.
+Risk-adjusted rates reveal the TRUTH: Telecom = +2.38% spread, P&amp;S = −2.38% spread. A 4% chasm.</a:t>
             </a:r>
           </a:p>
         </p:txBody>
@@ -18153,7 +18015,7 @@
                             <a:srgbClr val="FFFFFF"/>
                           </a:solidFill>
                         </a:rPr>
-                        <a:t>Actually</a:t>
+                        <a:t>Reality</a:t>
                       </a:r>
                     </a:p>
                   </a:txBody>
@@ -18265,7 +18127,7 @@
                             <a:srgbClr val="404040"/>
                           </a:solidFill>
                         </a:rPr>
-                        <a:t>Under-valued</a:t>
+                        <a:t>Undervalued!</a:t>
                       </a:r>
                     </a:p>
                   </a:txBody>
@@ -18541,11 +18403,11 @@
                   <a:srgbClr val="404040"/>
                 </a:solidFill>
               </a:rPr>
-              <a:t>• Telecom projects (ROIC 8.84%–9.30%) are REJECTED
+              <a:t>• Telecom projects (IRR 7.25%–9.30%) are REJECTED
   even though they create value  →  Type I Error
-• P&amp;S projects (ROIC 9.30%–11.22%) are ACCEPTED
-  even though they destroy value  →  Type II Error
-• Capital flows from value-creator to value-destroyer</a:t>
+  [Misallocated zone: 2.05 ppt wide!]
+• P&amp;S projects (IRR 9.30%–11.22%) are ACCEPTED
+  even though they destroy value  →  Type II Error</a:t>
             </a:r>
           </a:p>
         </p:txBody>
@@ -18821,7 +18683,7 @@
                             <a:srgbClr val="404040"/>
                           </a:solidFill>
                         </a:rPr>
-                        <a:t>8.84%</a:t>
+                        <a:t>7.25%</a:t>
                       </a:r>
                     </a:p>
                   </a:txBody>
@@ -18843,7 +18705,7 @@
                             <a:srgbClr val="404040"/>
                           </a:solidFill>
                         </a:rPr>
-                        <a:t>+0.79%</a:t>
+                        <a:t>+2.38%</a:t>
                       </a:r>
                     </a:p>
                   </a:txBody>
@@ -19142,10 +19004,10 @@
                 </a:solidFill>
               </a:rPr>
               <a:t>• Each segment faces its OWN cost of capital
-• Telecom receives MORE capital (strong value-creator)
-• P&amp;S receives LESS capital (value-destroyer)
-• Management incentives align with true risk
-• Eliminates the cross-subsidy mechanism</a:t>
+• Telecom receives MORE capital: strong +2.38% EVA
+• P&amp;S receives LESS: −2.38% EVA = value destroyer
+• Eliminates the 2 ppt+ cross-subsidy zone
+• Management incentives align with true risk</a:t>
             </a:r>
           </a:p>
         </p:txBody>
@@ -19265,7 +19127,7 @@
                   <a:srgbClr val="1B3A6B"/>
                 </a:solidFill>
               </a:rPr>
-              <a:t>Resource Allocation Implications (Q.a)</a:t>
+              <a:t>Resource Allocation Implication (Q.a)</a:t>
             </a:r>
           </a:p>
         </p:txBody>
@@ -19299,7 +19161,7 @@
                   <a:srgbClr val="404040"/>
                 </a:solidFill>
               </a:rPr>
-              <a:t>The uniform rate systematically channels capital toward the riskier segment and away from the safer segment — the opposite of what maximizes shareholder value.
+              <a:t>The uniform rate systematically starves Telecom (true WACC only 7.25%, but faces a 9.30% hurdle) while over-funding P&amp;S (true WACC 11.22%, but faces only a 9.30% hurdle).
 Conclusion: Risk-adjusted hurdle rates are the ONLY correct basis for multi-segment capital allocation.</a:t>
             </a:r>
           </a:p>
@@ -19480,7 +19342,7 @@
                   <a:srgbClr val="DEEBF7"/>
                 </a:solidFill>
               </a:rPr>
-              <a:t>EVA = (ROIC − WACC_segment) × Invested Capital  |  Equivalent to NPV for ongoing operations</a:t>
+              <a:t>EVA = (ROIC − WACC_segment) × Invested Capital  |  NPV-equivalent for ongoing operations</a:t>
             </a:r>
           </a:p>
         </p:txBody>
@@ -19908,7 +19770,7 @@
                             <a:srgbClr val="404040"/>
                           </a:solidFill>
                         </a:rPr>
-                        <a:t>8.84%</a:t>
+                        <a:t>7.25%</a:t>
                       </a:r>
                     </a:p>
                   </a:txBody>
@@ -19954,7 +19816,7 @@
                             <a:srgbClr val="404040"/>
                           </a:solidFill>
                         </a:rPr>
-                        <a:t>+0.79%</a:t>
+                        <a:t>+2.38%</a:t>
                       </a:r>
                     </a:p>
                   </a:txBody>
@@ -20046,7 +19908,7 @@
                             <a:srgbClr val="404040"/>
                           </a:solidFill>
                         </a:rPr>
-                        <a:t>+$69.2M  ✓</a:t>
+                        <a:t>+$208.5M  ✓</a:t>
                       </a:r>
                     </a:p>
                   </a:txBody>
@@ -20550,12 +20412,12 @@
           <a:p>
             <a:pPr algn="ctr"/>
             <a:r>
-              <a:rPr sz="1500" b="1" i="0">
+              <a:rPr sz="1400" b="1" i="0">
                 <a:solidFill>
                   <a:srgbClr val="FFFFFF"/>
                 </a:solidFill>
               </a:rPr>
-              <a:t>Net Annual EVA:  +$69.2M  −  $77.1M  =  −$7.9M  (firm is a NET value destroyer!)</a:t>
+              <a:t>Net Annual EVA:  +$208.5M  −  $77.1M  =  +$131.4M  (firm IS a net value creator — but P&amp;S is a $77M drag)</a:t>
             </a:r>
           </a:p>
         </p:txBody>
@@ -20569,7 +20431,7 @@
         <p:spPr>
           <a:xfrm>
             <a:off x="365760" y="5879592"/>
-            <a:ext cx="11430000" cy="347472"/>
+            <a:ext cx="11430000" cy="384048"/>
           </a:xfrm>
           <a:prstGeom prst="rect">
             <a:avLst/>
@@ -20612,7 +20474,7 @@
         <p:spPr>
           <a:xfrm>
             <a:off x="502920" y="5907024"/>
-            <a:ext cx="11155680" cy="320040"/>
+            <a:ext cx="11155680" cy="347472"/>
           </a:xfrm>
           <a:prstGeom prst="rect">
             <a:avLst/>
@@ -20632,7 +20494,7 @@
                   <a:srgbClr val="C00000"/>
                 </a:solidFill>
               </a:rPr>
-              <a:t>Conclusion: P&amp;S has ALREADY been destroying value. Switching to risk-adjusted rates reveals the problem — it does NOT cause it. The firm SHOULD implement risk-adjusted hurdle rates.</a:t>
+              <a:t>Critical finding: P&amp;S has ALREADY been destroying $77.1M/year. The uniform rate hides this by making both segments appear nearly equivalent in performance.</a:t>
             </a:r>
           </a:p>
         </p:txBody>

</xml_diff>

<commit_message>
style: remove Yin PANG from group members list
</commit_message>
<xml_diff>
--- a/TeleTech_Case4_Presentation.pptx
+++ b/TeleTech_Case4_Presentation.pptx
@@ -3361,7 +3361,7 @@
                   <a:srgbClr val="F2F2F2"/>
                 </a:solidFill>
               </a:rPr>
-              <a:t>Rangxila GONG  |  Huihui LIU  |  Yin PANG  |  Haiyun ZOU</a:t>
+              <a:t>Rangxila GONG  |  Huihui LIU  |  Haiyun ZOU</a:t>
             </a:r>
           </a:p>
         </p:txBody>
@@ -7478,7 +7478,7 @@
                   <a:srgbClr val="F2F2F2"/>
                 </a:solidFill>
               </a:rPr>
-              <a:t>Group 4: Rangxila GONG  |  Huihui LIU  |  Yin PANG  |  Haiyun ZOU</a:t>
+              <a:t>Rangxila GONG  |  Huihui LIU  |  Haiyun ZOU</a:t>
             </a:r>
           </a:p>
         </p:txBody>
@@ -14381,7 +14381,7 @@
 E/V = 91.41%
 D/E = 0.094
 Re-levered βL:
-0.856→1.244×1.056 = 1.315
+1.244×1.056 = 1.315
 Cost of Equity:
 4.62%+1.315×5.50% = 11.85%
 Cost of Debt (BB):

</xml_diff>

<commit_message>
fix: remove hypothetical IRR numbers from Slide 9 (Q.a)
Replace fabricated IRR examples with conceptual description of
Type I / Type II decision errors using only case-provided ROC data
</commit_message>
<xml_diff>
--- a/TeleTech_Case4_Presentation.pptx
+++ b/TeleTech_Case4_Presentation.pptx
@@ -12972,7 +12972,7 @@
      = 4.62% + 5.72%
      = 10.34%
 Cost of Debt (A-rated):
-  rd = 5.74% (Exhibit 1 &amp; 4)
+  rd = 5.74% (Exhibit 4)
 WACC:
   0.729×10.34%
   + 0.271×5.74%×0.60
@@ -16723,264 +16723,228 @@
           </a:p>
         </p:txBody>
       </p:sp>
-      <p:graphicFrame>
-        <p:nvGraphicFramePr>
-          <p:cNvPr id="33" name="Table 32"/>
-          <p:cNvGraphicFramePr>
-            <a:graphicFrameLocks noGrp="1"/>
-          </p:cNvGraphicFramePr>
-          <p:nvPr/>
-        </p:nvGraphicFramePr>
-        <p:xfrm>
-          <a:off x="274320" y="5532120"/>
-          <a:ext cx="11612880" cy="1051560"/>
-        </p:xfrm>
-        <a:graphic>
-          <a:graphicData uri="http://schemas.openxmlformats.org/drawingml/2006/table">
-            <a:tbl>
-              <a:tblPr firstRow="1" bandRow="1">
-                <a:tableStyleId>{5C22544A-7EE6-4342-B048-85BDC9FD1C3A}</a:tableStyleId>
-              </a:tblPr>
-              <a:tblGrid>
-                <a:gridCol w="2903220"/>
-                <a:gridCol w="2903220"/>
-                <a:gridCol w="2903220"/>
-                <a:gridCol w="2903220"/>
-              </a:tblGrid>
-              <a:tr h="350520">
-                <a:tc>
-                  <a:txBody>
-                    <a:bodyPr/>
-                    <a:lstStyle/>
-                    <a:p>
-                      <a:pPr algn="ctr"/>
-                      <a:r>
-                        <a:rPr sz="1100" b="1">
-                          <a:solidFill>
-                            <a:srgbClr val="FFFFFF"/>
-                          </a:solidFill>
-                        </a:rPr>
-                        <a:t>Project</a:t>
-                      </a:r>
-                    </a:p>
-                  </a:txBody>
-                  <a:tcPr>
-                    <a:solidFill>
-                      <a:srgbClr val="1F3964"/>
-                    </a:solidFill>
-                  </a:tcPr>
-                </a:tc>
-                <a:tc>
-                  <a:txBody>
-                    <a:bodyPr/>
-                    <a:lstStyle/>
-                    <a:p>
-                      <a:pPr algn="ctr"/>
-                      <a:r>
-                        <a:rPr sz="1100" b="1">
-                          <a:solidFill>
-                            <a:srgbClr val="FFFFFF"/>
-                          </a:solidFill>
-                        </a:rPr>
-                        <a:t>Uniform Rate</a:t>
-                      </a:r>
-                    </a:p>
-                  </a:txBody>
-                  <a:tcPr>
-                    <a:solidFill>
-                      <a:srgbClr val="1F3964"/>
-                    </a:solidFill>
-                  </a:tcPr>
-                </a:tc>
-                <a:tc>
-                  <a:txBody>
-                    <a:bodyPr/>
-                    <a:lstStyle/>
-                    <a:p>
-                      <a:pPr algn="ctr"/>
-                      <a:r>
-                        <a:rPr sz="1100" b="1">
-                          <a:solidFill>
-                            <a:srgbClr val="FFFFFF"/>
-                          </a:solidFill>
-                        </a:rPr>
-                        <a:t>Risk-Adj. Rate</a:t>
-                      </a:r>
-                    </a:p>
-                  </a:txBody>
-                  <a:tcPr>
-                    <a:solidFill>
-                      <a:srgbClr val="1F3964"/>
-                    </a:solidFill>
-                  </a:tcPr>
-                </a:tc>
-                <a:tc>
-                  <a:txBody>
-                    <a:bodyPr/>
-                    <a:lstStyle/>
-                    <a:p>
-                      <a:pPr algn="ctr"/>
-                      <a:r>
-                        <a:rPr sz="1100" b="1">
-                          <a:solidFill>
-                            <a:srgbClr val="FFFFFF"/>
-                          </a:solidFill>
-                        </a:rPr>
-                        <a:t>Error Type</a:t>
-                      </a:r>
-                    </a:p>
-                  </a:txBody>
-                  <a:tcPr>
-                    <a:solidFill>
-                      <a:srgbClr val="1F3964"/>
-                    </a:solidFill>
-                  </a:tcPr>
-                </a:tc>
-              </a:tr>
-              <a:tr h="350520">
-                <a:tc>
-                  <a:txBody>
-                    <a:bodyPr/>
-                    <a:lstStyle/>
-                    <a:p>
-                      <a:pPr algn="ctr"/>
-                      <a:r>
-                        <a:rPr sz="1100" b="0"/>
-                        <a:t>Telecom IRR = 9.00%</a:t>
-                      </a:r>
-                    </a:p>
-                  </a:txBody>
-                  <a:tcPr>
-                    <a:noFill/>
-                  </a:tcPr>
-                </a:tc>
-                <a:tc>
-                  <a:txBody>
-                    <a:bodyPr/>
-                    <a:lstStyle/>
-                    <a:p>
-                      <a:pPr algn="ctr"/>
-                      <a:r>
-                        <a:rPr sz="1100" b="0"/>
-                        <a:t>REJECT (&lt; 9.30%)</a:t>
-                      </a:r>
-                    </a:p>
-                  </a:txBody>
-                  <a:tcPr>
-                    <a:noFill/>
-                  </a:tcPr>
-                </a:tc>
-                <a:tc>
-                  <a:txBody>
-                    <a:bodyPr/>
-                    <a:lstStyle/>
-                    <a:p>
-                      <a:pPr algn="ctr"/>
-                      <a:r>
-                        <a:rPr sz="1100" b="0"/>
-                        <a:t>ACCEPT (&gt; 8.47%)</a:t>
-                      </a:r>
-                    </a:p>
-                  </a:txBody>
-                  <a:tcPr>
-                    <a:noFill/>
-                  </a:tcPr>
-                </a:tc>
-                <a:tc>
-                  <a:txBody>
-                    <a:bodyPr/>
-                    <a:lstStyle/>
-                    <a:p>
-                      <a:pPr algn="ctr"/>
-                      <a:r>
-                        <a:rPr sz="1100" b="0"/>
-                        <a:t>Type I ✗</a:t>
-                      </a:r>
-                    </a:p>
-                  </a:txBody>
-                  <a:tcPr>
-                    <a:noFill/>
-                  </a:tcPr>
-                </a:tc>
-              </a:tr>
-              <a:tr h="350520">
-                <a:tc>
-                  <a:txBody>
-                    <a:bodyPr/>
-                    <a:lstStyle/>
-                    <a:p>
-                      <a:pPr algn="ctr"/>
-                      <a:r>
-                        <a:rPr sz="1100" b="0"/>
-                        <a:t>P&amp;S IRR = 10.50%</a:t>
-                      </a:r>
-                    </a:p>
-                  </a:txBody>
-                  <a:tcPr>
-                    <a:solidFill>
-                      <a:srgbClr val="F2F2F2"/>
-                    </a:solidFill>
-                  </a:tcPr>
-                </a:tc>
-                <a:tc>
-                  <a:txBody>
-                    <a:bodyPr/>
-                    <a:lstStyle/>
-                    <a:p>
-                      <a:pPr algn="ctr"/>
-                      <a:r>
-                        <a:rPr sz="1100" b="0"/>
-                        <a:t>ACCEPT (&gt; 9.30%)</a:t>
-                      </a:r>
-                    </a:p>
-                  </a:txBody>
-                  <a:tcPr>
-                    <a:solidFill>
-                      <a:srgbClr val="F2F2F2"/>
-                    </a:solidFill>
-                  </a:tcPr>
-                </a:tc>
-                <a:tc>
-                  <a:txBody>
-                    <a:bodyPr/>
-                    <a:lstStyle/>
-                    <a:p>
-                      <a:pPr algn="ctr"/>
-                      <a:r>
-                        <a:rPr sz="1100" b="0"/>
-                        <a:t>REJECT (&lt; 11.40%)</a:t>
-                      </a:r>
-                    </a:p>
-                  </a:txBody>
-                  <a:tcPr>
-                    <a:solidFill>
-                      <a:srgbClr val="F2F2F2"/>
-                    </a:solidFill>
-                  </a:tcPr>
-                </a:tc>
-                <a:tc>
-                  <a:txBody>
-                    <a:bodyPr/>
-                    <a:lstStyle/>
-                    <a:p>
-                      <a:pPr algn="ctr"/>
-                      <a:r>
-                        <a:rPr sz="1100" b="0"/>
-                        <a:t>Type II ✗</a:t>
-                      </a:r>
-                    </a:p>
-                  </a:txBody>
-                  <a:tcPr>
-                    <a:solidFill>
-                      <a:srgbClr val="F2F2F2"/>
-                    </a:solidFill>
-                  </a:tcPr>
-                </a:tc>
-              </a:tr>
-            </a:tbl>
-          </a:graphicData>
-        </a:graphic>
-      </p:graphicFrame>
+      <p:sp>
+        <p:nvSpPr>
+          <p:cNvPr id="33" name="Rectangle 32"/>
+          <p:cNvSpPr/>
+          <p:nvPr/>
+        </p:nvSpPr>
+        <p:spPr>
+          <a:xfrm>
+            <a:off x="274320" y="5532120"/>
+            <a:ext cx="5486400" cy="1097280"/>
+          </a:xfrm>
+          <a:prstGeom prst="rect">
+            <a:avLst/>
+          </a:prstGeom>
+          <a:solidFill>
+            <a:srgbClr val="C00000"/>
+          </a:solidFill>
+          <a:ln>
+            <a:noFill/>
+          </a:ln>
+        </p:spPr>
+        <p:style>
+          <a:lnRef idx="1">
+            <a:schemeClr val="accent1"/>
+          </a:lnRef>
+          <a:fillRef idx="3">
+            <a:schemeClr val="accent1"/>
+          </a:fillRef>
+          <a:effectRef idx="2">
+            <a:schemeClr val="accent1"/>
+          </a:effectRef>
+          <a:fontRef idx="minor">
+            <a:schemeClr val="lt1"/>
+          </a:fontRef>
+        </p:style>
+        <p:txBody>
+          <a:bodyPr rtlCol="0" anchor="ctr"/>
+          <a:lstStyle/>
+          <a:p>
+            <a:pPr algn="ctr"/>
+          </a:p>
+        </p:txBody>
+      </p:sp>
+      <p:sp>
+        <p:nvSpPr>
+          <p:cNvPr id="34" name="TextBox 33"/>
+          <p:cNvSpPr txBox="1"/>
+          <p:nvPr/>
+        </p:nvSpPr>
+        <p:spPr>
+          <a:xfrm>
+            <a:off x="411480" y="5559552"/>
+            <a:ext cx="5212080" cy="347472"/>
+          </a:xfrm>
+          <a:prstGeom prst="rect">
+            <a:avLst/>
+          </a:prstGeom>
+          <a:noFill/>
+        </p:spPr>
+        <p:txBody>
+          <a:bodyPr wrap="square">
+            <a:spAutoFit/>
+          </a:bodyPr>
+          <a:lstStyle/>
+          <a:p>
+            <a:pPr algn="l"/>
+            <a:r>
+              <a:rPr sz="1100" b="1" i="0">
+                <a:solidFill>
+                  <a:srgbClr val="FFFFFF"/>
+                </a:solidFill>
+              </a:rPr>
+              <a:t>Type I Error — Underinvestment in Telecom</a:t>
+            </a:r>
+          </a:p>
+        </p:txBody>
+      </p:sp>
+      <p:sp>
+        <p:nvSpPr>
+          <p:cNvPr id="35" name="TextBox 34"/>
+          <p:cNvSpPr txBox="1"/>
+          <p:nvPr/>
+        </p:nvSpPr>
+        <p:spPr>
+          <a:xfrm>
+            <a:off x="411480" y="5925312"/>
+            <a:ext cx="5212080" cy="640080"/>
+          </a:xfrm>
+          <a:prstGeom prst="rect">
+            <a:avLst/>
+          </a:prstGeom>
+          <a:noFill/>
+        </p:spPr>
+        <p:txBody>
+          <a:bodyPr wrap="square">
+            <a:spAutoFit/>
+          </a:bodyPr>
+          <a:lstStyle/>
+          <a:p>
+            <a:pPr algn="l"/>
+            <a:r>
+              <a:rPr sz="950" b="0" i="0">
+                <a:solidFill>
+                  <a:srgbClr val="FFFFFF"/>
+                </a:solidFill>
+              </a:rPr>
+              <a:t>Projects in Telecom with returns between 8.47%–9.30% are genuine value-creators but get wrongly rejected under the 9.30% uniform rate.</a:t>
+            </a:r>
+          </a:p>
+        </p:txBody>
+      </p:sp>
+      <p:sp>
+        <p:nvSpPr>
+          <p:cNvPr id="36" name="Rectangle 35"/>
+          <p:cNvSpPr/>
+          <p:nvPr/>
+        </p:nvSpPr>
+        <p:spPr>
+          <a:xfrm>
+            <a:off x="5943600" y="5532120"/>
+            <a:ext cx="5943600" cy="1097280"/>
+          </a:xfrm>
+          <a:prstGeom prst="rect">
+            <a:avLst/>
+          </a:prstGeom>
+          <a:solidFill>
+            <a:srgbClr val="C05000"/>
+          </a:solidFill>
+          <a:ln>
+            <a:noFill/>
+          </a:ln>
+        </p:spPr>
+        <p:style>
+          <a:lnRef idx="1">
+            <a:schemeClr val="accent1"/>
+          </a:lnRef>
+          <a:fillRef idx="3">
+            <a:schemeClr val="accent1"/>
+          </a:fillRef>
+          <a:effectRef idx="2">
+            <a:schemeClr val="accent1"/>
+          </a:effectRef>
+          <a:fontRef idx="minor">
+            <a:schemeClr val="lt1"/>
+          </a:fontRef>
+        </p:style>
+        <p:txBody>
+          <a:bodyPr rtlCol="0" anchor="ctr"/>
+          <a:lstStyle/>
+          <a:p>
+            <a:pPr algn="ctr"/>
+          </a:p>
+        </p:txBody>
+      </p:sp>
+      <p:sp>
+        <p:nvSpPr>
+          <p:cNvPr id="37" name="TextBox 36"/>
+          <p:cNvSpPr txBox="1"/>
+          <p:nvPr/>
+        </p:nvSpPr>
+        <p:spPr>
+          <a:xfrm>
+            <a:off x="6080760" y="5559552"/>
+            <a:ext cx="5669280" cy="347472"/>
+          </a:xfrm>
+          <a:prstGeom prst="rect">
+            <a:avLst/>
+          </a:prstGeom>
+          <a:noFill/>
+        </p:spPr>
+        <p:txBody>
+          <a:bodyPr wrap="square">
+            <a:spAutoFit/>
+          </a:bodyPr>
+          <a:lstStyle/>
+          <a:p>
+            <a:pPr algn="l"/>
+            <a:r>
+              <a:rPr sz="1100" b="1" i="0">
+                <a:solidFill>
+                  <a:srgbClr val="FFFFFF"/>
+                </a:solidFill>
+              </a:rPr>
+              <a:t>Type II Error — Overinvestment in P&amp;S</a:t>
+            </a:r>
+          </a:p>
+        </p:txBody>
+      </p:sp>
+      <p:sp>
+        <p:nvSpPr>
+          <p:cNvPr id="38" name="TextBox 37"/>
+          <p:cNvSpPr txBox="1"/>
+          <p:nvPr/>
+        </p:nvSpPr>
+        <p:spPr>
+          <a:xfrm>
+            <a:off x="6080760" y="5925312"/>
+            <a:ext cx="5669280" cy="640080"/>
+          </a:xfrm>
+          <a:prstGeom prst="rect">
+            <a:avLst/>
+          </a:prstGeom>
+          <a:noFill/>
+        </p:spPr>
+        <p:txBody>
+          <a:bodyPr wrap="square">
+            <a:spAutoFit/>
+          </a:bodyPr>
+          <a:lstStyle/>
+          <a:p>
+            <a:pPr algn="l"/>
+            <a:r>
+              <a:rPr sz="950" b="0" i="0">
+                <a:solidFill>
+                  <a:srgbClr val="FFFFFF"/>
+                </a:solidFill>
+              </a:rPr>
+              <a:t>Projects in P&amp;S with returns between 9.30%–11.40% appear profitable under the uniform rate but are actually value-destroying once risk is properly priced.</a:t>
+            </a:r>
+          </a:p>
+        </p:txBody>
+      </p:sp>
     </p:spTree>
   </p:cSld>
   <p:clrMapOvr>

</xml_diff>